<commit_message>
Stage 3: say 'GPU workstation' for the experiment hardware; notebook fetches stored results when run standalone; rebuild report, deck, zip
</commit_message>
<xml_diff>
--- a/stage3/PINNacles_Stage3_FinalPresentation.pptx
+++ b/stage3/PINNacles_Stage3_FinalPresentation.pptx
@@ -6847,7 +6847,7 @@
               </a:defRPr>
             </a:pPr>
             <a:r>
-              <a:t>•  142 training runs on one shared GPU workstation; all configs and metrics stored per run</a:t>
+              <a:t>•  142 training runs on one GPU workstation; all configs and metrics stored per run</a:t>
             </a:r>
           </a:p>
         </p:txBody>
@@ -11014,7 +11014,7 @@
               </a:defRPr>
             </a:pPr>
             <a:r>
-              <a:t>CUDA-event timing on an idle Blackwell GPU; CPU numbers from a shared host (indicative)</a:t>
+              <a:t>CUDA-event timing on an idle GPU; CPU numbers from the workstation CPU (indicative)</a:t>
             </a:r>
           </a:p>
         </p:txBody>

</xml_diff>